<commit_message>
Update 1초 송퀴즈 assets and add ZIP slides
Co-Authored-By: Claude Opus 4.6 (1M context) <noreply@anthropic.com>
</commit_message>
<xml_diff>
--- a/public/downloads/games/one-second-song/rules.pptx
+++ b/public/downloads/games/one-second-song/rules.pptx
@@ -15,16 +15,12 @@
   <p:notesSz cx="6858000" cy="9144000"/>
   <p:embeddedFontLst>
     <p:embeddedFont>
-      <p:font typeface="Jua" charset="1" panose="00000000000000000000"/>
+      <p:font typeface="무궁화 고딕" charset="1" panose="02020603020101020101"/>
       <p:regular r:id="rId11"/>
     </p:embeddedFont>
     <p:embeddedFont>
-      <p:font typeface="TDTD갬성명조" charset="1" panose="02000503000000000000"/>
+      <p:font typeface="무궁화 고딕 Bold" charset="1" panose="02020603020101020101"/>
       <p:regular r:id="rId12"/>
-    </p:embeddedFont>
-    <p:embeddedFont>
-      <p:font typeface="TDTD가온" charset="1" panose="02000503000000000000"/>
-      <p:regular r:id="rId13"/>
     </p:embeddedFont>
   </p:embeddedFontLst>
   <p:defaultTextStyle>
@@ -3142,8 +3138,8 @@
         </p:nvSpPr>
         <p:spPr>
           <a:xfrm rot="0">
-            <a:off x="1028700" y="3892867"/>
-            <a:ext cx="15555091" cy="2200275"/>
+            <a:off x="1028700" y="4178617"/>
+            <a:ext cx="15555091" cy="1914525"/>
           </a:xfrm>
           <a:prstGeom prst="rect">
             <a:avLst/>
@@ -3165,10 +3161,10 @@
                 <a:solidFill>
                   <a:srgbClr val="FFFAEF"/>
                 </a:solidFill>
-                <a:latin typeface="Jua"/>
-                <a:ea typeface="Jua"/>
-                <a:cs typeface="Jua"/>
-                <a:sym typeface="Jua"/>
+                <a:latin typeface="무궁화 고딕"/>
+                <a:ea typeface="무궁화 고딕"/>
+                <a:cs typeface="무궁화 고딕"/>
+                <a:sym typeface="무궁화 고딕"/>
               </a:rPr>
               <a:t>1초 송퀴즈</a:t>
             </a:r>
@@ -3183,8 +3179,8 @@
         </p:nvSpPr>
         <p:spPr>
           <a:xfrm rot="0">
-            <a:off x="15264803" y="9812655"/>
-            <a:ext cx="2637975" cy="474345"/>
+            <a:off x="14843698" y="9822180"/>
+            <a:ext cx="3059081" cy="464820"/>
           </a:xfrm>
           <a:prstGeom prst="rect">
             <a:avLst/>
@@ -3209,10 +3205,10 @@
                 <a:solidFill>
                   <a:srgbClr val="FFFFFF"/>
                 </a:solidFill>
-                <a:latin typeface="TDTD갬성명조"/>
-                <a:ea typeface="TDTD갬성명조"/>
-                <a:cs typeface="TDTD갬성명조"/>
-                <a:sym typeface="TDTD갬성명조"/>
+                <a:latin typeface="무궁화 고딕"/>
+                <a:ea typeface="무궁화 고딕"/>
+                <a:cs typeface="무궁화 고딕"/>
+                <a:sym typeface="무궁화 고딕"/>
               </a:rPr>
               <a:t>ⓒ 2026. Sunday Play</a:t>
             </a:r>
@@ -3361,8 +3357,8 @@
         </p:nvSpPr>
         <p:spPr>
           <a:xfrm rot="0">
-            <a:off x="11392761" y="600705"/>
-            <a:ext cx="5362043" cy="1600200"/>
+            <a:off x="11392761" y="819780"/>
+            <a:ext cx="5362043" cy="1381125"/>
           </a:xfrm>
           <a:prstGeom prst="rect">
             <a:avLst/>
@@ -3384,10 +3380,10 @@
                 <a:solidFill>
                   <a:srgbClr val="FFFAEF"/>
                 </a:solidFill>
-                <a:latin typeface="Jua"/>
-                <a:ea typeface="Jua"/>
-                <a:cs typeface="Jua"/>
-                <a:sym typeface="Jua"/>
+                <a:latin typeface="무궁화 고딕"/>
+                <a:ea typeface="무궁화 고딕"/>
+                <a:cs typeface="무궁화 고딕"/>
+                <a:sym typeface="무궁화 고딕"/>
               </a:rPr>
               <a:t>규칙</a:t>
             </a:r>
@@ -3403,9 +3399,9 @@
         <p:grpSpPr>
           <a:xfrm rot="0">
             <a:off x="309172" y="535073"/>
-            <a:ext cx="11933749" cy="2128845"/>
+            <a:ext cx="11933749" cy="1973270"/>
             <a:chOff x="0" y="0"/>
-            <a:chExt cx="15911666" cy="2838461"/>
+            <a:chExt cx="15911666" cy="2631026"/>
           </a:xfrm>
         </p:grpSpPr>
         <p:sp>
@@ -3416,8 +3412,8 @@
           </p:nvSpPr>
           <p:spPr>
             <a:xfrm rot="0">
-              <a:off x="0" y="1615026"/>
-              <a:ext cx="15911666" cy="1223435"/>
+              <a:off x="0" y="1643601"/>
+              <a:ext cx="15911666" cy="987426"/>
             </a:xfrm>
             <a:prstGeom prst="rect">
               <a:avLst/>
@@ -3431,18 +3427,18 @@
             <a:p>
               <a:pPr algn="l">
                 <a:lnSpc>
-                  <a:spcPts val="7699"/>
+                  <a:spcPts val="6299"/>
                 </a:lnSpc>
               </a:pPr>
               <a:r>
-                <a:rPr lang="en-US" sz="5499">
+                <a:rPr lang="en-US" sz="4499">
                   <a:solidFill>
                     <a:srgbClr val="FFFAEF"/>
                   </a:solidFill>
-                  <a:latin typeface="TDTD가온"/>
-                  <a:ea typeface="TDTD가온"/>
-                  <a:cs typeface="TDTD가온"/>
-                  <a:sym typeface="TDTD가온"/>
+                  <a:latin typeface="무궁화 고딕"/>
+                  <a:ea typeface="무궁화 고딕"/>
+                  <a:cs typeface="무궁화 고딕"/>
+                  <a:sym typeface="무궁화 고딕"/>
                 </a:rPr>
                 <a:t>노래가 1초만 재생됩니다. 집중하세요!</a:t>
               </a:r>
@@ -3457,8 +3453,8 @@
           </p:nvSpPr>
           <p:spPr>
             <a:xfrm rot="0">
-              <a:off x="0" y="-200025"/>
-              <a:ext cx="10684245" cy="1406526"/>
+              <a:off x="0" y="-57150"/>
+              <a:ext cx="10684245" cy="1263651"/>
             </a:xfrm>
             <a:prstGeom prst="rect">
               <a:avLst/>
@@ -3480,10 +3476,10 @@
                   <a:solidFill>
                     <a:srgbClr val="FFFAEF"/>
                   </a:solidFill>
-                  <a:latin typeface="Jua"/>
-                  <a:ea typeface="Jua"/>
-                  <a:cs typeface="Jua"/>
-                  <a:sym typeface="Jua"/>
+                  <a:latin typeface="무궁화 고딕 Bold"/>
+                  <a:ea typeface="무궁화 고딕 Bold"/>
+                  <a:cs typeface="무궁화 고딕 Bold"/>
+                  <a:sym typeface="무궁화 고딕 Bold"/>
                 </a:rPr>
                 <a:t>STEP 1.</a:t>
               </a:r>
@@ -3499,10 +3495,10 @@
         </p:nvGrpSpPr>
         <p:grpSpPr>
           <a:xfrm rot="0">
-            <a:off x="11392761" y="7389599"/>
-            <a:ext cx="6694713" cy="2123982"/>
+            <a:off x="11392761" y="7809938"/>
+            <a:ext cx="6694713" cy="1968407"/>
             <a:chOff x="0" y="0"/>
-            <a:chExt cx="8926284" cy="2831976"/>
+            <a:chExt cx="8926284" cy="2624542"/>
           </a:xfrm>
         </p:grpSpPr>
         <p:sp>
@@ -3513,8 +3509,8 @@
           </p:nvSpPr>
           <p:spPr>
             <a:xfrm rot="0">
-              <a:off x="0" y="1608541"/>
-              <a:ext cx="8785636" cy="1223436"/>
+              <a:off x="0" y="1637116"/>
+              <a:ext cx="8785636" cy="987427"/>
             </a:xfrm>
             <a:prstGeom prst="rect">
               <a:avLst/>
@@ -3528,18 +3524,18 @@
             <a:p>
               <a:pPr algn="l">
                 <a:lnSpc>
-                  <a:spcPts val="7699"/>
+                  <a:spcPts val="6299"/>
                 </a:lnSpc>
               </a:pPr>
               <a:r>
-                <a:rPr lang="en-US" sz="5499">
+                <a:rPr lang="en-US" sz="4499">
                   <a:solidFill>
                     <a:srgbClr val="FFFAEF"/>
                   </a:solidFill>
-                  <a:latin typeface="TDTD가온"/>
-                  <a:ea typeface="TDTD가온"/>
-                  <a:cs typeface="TDTD가온"/>
-                  <a:sym typeface="TDTD가온"/>
+                  <a:latin typeface="무궁화 고딕"/>
+                  <a:ea typeface="무궁화 고딕"/>
+                  <a:cs typeface="무궁화 고딕"/>
+                  <a:sym typeface="무궁화 고딕"/>
                 </a:rPr>
                 <a:t>가장 많이 맞춘 팀이 우승!</a:t>
               </a:r>
@@ -3554,8 +3550,8 @@
           </p:nvSpPr>
           <p:spPr>
             <a:xfrm rot="0">
-              <a:off x="0" y="-200025"/>
-              <a:ext cx="8926284" cy="1406526"/>
+              <a:off x="0" y="-57150"/>
+              <a:ext cx="8926284" cy="1263651"/>
             </a:xfrm>
             <a:prstGeom prst="rect">
               <a:avLst/>
@@ -3577,10 +3573,10 @@
                   <a:solidFill>
                     <a:srgbClr val="FFFAEF"/>
                   </a:solidFill>
-                  <a:latin typeface="Jua"/>
-                  <a:ea typeface="Jua"/>
-                  <a:cs typeface="Jua"/>
-                  <a:sym typeface="Jua"/>
+                  <a:latin typeface="무궁화 고딕 Bold"/>
+                  <a:ea typeface="무궁화 고딕 Bold"/>
+                  <a:cs typeface="무궁화 고딕 Bold"/>
+                  <a:sym typeface="무궁화 고딕 Bold"/>
                 </a:rPr>
                 <a:t>STEP 3.</a:t>
               </a:r>
@@ -3596,10 +3592,10 @@
         </p:nvGrpSpPr>
         <p:grpSpPr>
           <a:xfrm rot="0">
-            <a:off x="4893094" y="3710034"/>
-            <a:ext cx="8501812" cy="2123982"/>
+            <a:off x="4893094" y="4174938"/>
+            <a:ext cx="8501812" cy="1968405"/>
             <a:chOff x="0" y="0"/>
-            <a:chExt cx="11335749" cy="2831976"/>
+            <a:chExt cx="11335749" cy="2624541"/>
           </a:xfrm>
         </p:grpSpPr>
         <p:sp>
@@ -3610,8 +3606,8 @@
           </p:nvSpPr>
           <p:spPr>
             <a:xfrm rot="0">
-              <a:off x="0" y="1608540"/>
-              <a:ext cx="11335749" cy="1223436"/>
+              <a:off x="0" y="1637115"/>
+              <a:ext cx="11335749" cy="987426"/>
             </a:xfrm>
             <a:prstGeom prst="rect">
               <a:avLst/>
@@ -3625,18 +3621,18 @@
             <a:p>
               <a:pPr algn="l">
                 <a:lnSpc>
-                  <a:spcPts val="7699"/>
+                  <a:spcPts val="6299"/>
                 </a:lnSpc>
               </a:pPr>
               <a:r>
-                <a:rPr lang="en-US" sz="5499">
+                <a:rPr lang="en-US" sz="4499">
                   <a:solidFill>
                     <a:srgbClr val="FFFAEF"/>
                   </a:solidFill>
-                  <a:latin typeface="TDTD가온"/>
-                  <a:ea typeface="TDTD가온"/>
-                  <a:cs typeface="TDTD가온"/>
-                  <a:sym typeface="TDTD가온"/>
+                  <a:latin typeface="무궁화 고딕"/>
+                  <a:ea typeface="무궁화 고딕"/>
+                  <a:cs typeface="무궁화 고딕"/>
+                  <a:sym typeface="무궁화 고딕"/>
                 </a:rPr>
                 <a:t>어떤 노래인지 가장 먼저 외치세요!</a:t>
               </a:r>
@@ -3651,8 +3647,8 @@
           </p:nvSpPr>
           <p:spPr>
             <a:xfrm rot="0">
-              <a:off x="0" y="-200025"/>
-              <a:ext cx="7235855" cy="1406526"/>
+              <a:off x="0" y="-57150"/>
+              <a:ext cx="7235855" cy="1263651"/>
             </a:xfrm>
             <a:prstGeom prst="rect">
               <a:avLst/>
@@ -3674,10 +3670,10 @@
                   <a:solidFill>
                     <a:srgbClr val="FFFAEF"/>
                   </a:solidFill>
-                  <a:latin typeface="Jua"/>
-                  <a:ea typeface="Jua"/>
-                  <a:cs typeface="Jua"/>
-                  <a:sym typeface="Jua"/>
+                  <a:latin typeface="무궁화 고딕 Bold"/>
+                  <a:ea typeface="무궁화 고딕 Bold"/>
+                  <a:cs typeface="무궁화 고딕 Bold"/>
+                  <a:sym typeface="무궁화 고딕 Bold"/>
                 </a:rPr>
                 <a:t>STEP 2.</a:t>
               </a:r>
@@ -3725,8 +3721,8 @@
         </p:nvSpPr>
         <p:spPr>
           <a:xfrm rot="0">
-            <a:off x="3238925" y="4092795"/>
-            <a:ext cx="11810151" cy="2200275"/>
+            <a:off x="3238925" y="4378545"/>
+            <a:ext cx="11810151" cy="1914525"/>
           </a:xfrm>
           <a:prstGeom prst="rect">
             <a:avLst/>
@@ -3748,10 +3744,10 @@
                 <a:solidFill>
                   <a:srgbClr val="000000"/>
                 </a:solidFill>
-                <a:latin typeface="Jua"/>
-                <a:ea typeface="Jua"/>
-                <a:cs typeface="Jua"/>
-                <a:sym typeface="Jua"/>
+                <a:latin typeface="무궁화 고딕"/>
+                <a:ea typeface="무궁화 고딕"/>
+                <a:cs typeface="무궁화 고딕"/>
+                <a:sym typeface="무궁화 고딕"/>
               </a:rPr>
               <a:t>팀을 나눠주세요!</a:t>
             </a:r>
@@ -3898,8 +3894,8 @@
         </p:nvSpPr>
         <p:spPr>
           <a:xfrm rot="0">
-            <a:off x="1028700" y="3892867"/>
-            <a:ext cx="15555091" cy="2200275"/>
+            <a:off x="1028700" y="4178617"/>
+            <a:ext cx="15555091" cy="1914525"/>
           </a:xfrm>
           <a:prstGeom prst="rect">
             <a:avLst/>
@@ -3921,10 +3917,10 @@
                 <a:solidFill>
                   <a:srgbClr val="FFFAEF"/>
                 </a:solidFill>
-                <a:latin typeface="Jua"/>
-                <a:ea typeface="Jua"/>
-                <a:cs typeface="Jua"/>
-                <a:sym typeface="Jua"/>
+                <a:latin typeface="무궁화 고딕"/>
+                <a:ea typeface="무궁화 고딕"/>
+                <a:cs typeface="무궁화 고딕"/>
+                <a:sym typeface="무궁화 고딕"/>
               </a:rPr>
               <a:t>1초 송퀴즈</a:t>
             </a:r>
@@ -3939,8 +3935,8 @@
         </p:nvSpPr>
         <p:spPr>
           <a:xfrm rot="0">
-            <a:off x="15264803" y="9812655"/>
-            <a:ext cx="2637975" cy="474345"/>
+            <a:off x="14843698" y="9822180"/>
+            <a:ext cx="3059081" cy="464820"/>
           </a:xfrm>
           <a:prstGeom prst="rect">
             <a:avLst/>
@@ -3965,10 +3961,10 @@
                 <a:solidFill>
                   <a:srgbClr val="FFFFFF"/>
                 </a:solidFill>
-                <a:latin typeface="TDTD갬성명조"/>
-                <a:ea typeface="TDTD갬성명조"/>
-                <a:cs typeface="TDTD갬성명조"/>
-                <a:sym typeface="TDTD갬성명조"/>
+                <a:latin typeface="무궁화 고딕"/>
+                <a:ea typeface="무궁화 고딕"/>
+                <a:cs typeface="무궁화 고딕"/>
+                <a:sym typeface="무궁화 고딕"/>
               </a:rPr>
               <a:t>ⓒ 2026. Sunday Play</a:t>
             </a:r>
@@ -4040,8 +4036,8 @@
         </p:nvSpPr>
         <p:spPr>
           <a:xfrm rot="0">
-            <a:off x="4421807" y="3895725"/>
-            <a:ext cx="9444385" cy="2200275"/>
+            <a:off x="4421807" y="4181475"/>
+            <a:ext cx="9444385" cy="1914525"/>
           </a:xfrm>
           <a:prstGeom prst="rect">
             <a:avLst/>
@@ -4063,10 +4059,10 @@
                 <a:solidFill>
                   <a:srgbClr val="000000"/>
                 </a:solidFill>
-                <a:latin typeface="Jua"/>
-                <a:ea typeface="Jua"/>
-                <a:cs typeface="Jua"/>
-                <a:sym typeface="Jua"/>
+                <a:latin typeface="무궁화 고딕"/>
+                <a:ea typeface="무궁화 고딕"/>
+                <a:cs typeface="무궁화 고딕"/>
+                <a:sym typeface="무궁화 고딕"/>
               </a:rPr>
               <a:t>감사합니다!</a:t>
             </a:r>

</xml_diff>